<commit_message>
more small UIUX changes
</commit_message>
<xml_diff>
--- a/backend/blank/blank.pptx
+++ b/backend/blank/blank.pptx
@@ -8,7 +8,7 @@
   <p:notesSz cx="6858000" cy="9144000"/>
   <p:defaultTextStyle>
     <a:defPPr>
-      <a:defRPr lang="en-US"/>
+      <a:defRPr lang="de-DE"/>
     </a:defPPr>
     <a:lvl1pPr marL="0" algn="l" defTabSz="457200" rtl="0" eaLnBrk="1" latinLnBrk="0" hangingPunct="1">
       <a:defRPr sz="1800" kern="1200">
@@ -142,10 +142,10 @@
           <a:lstStyle/>
           <a:p>
             <a:r>
-              <a:rPr lang="en-US" smtClean="0"/>
+              <a:rPr lang="de-DE" smtClean="0"/>
               <a:t>Click to edit Master title style</a:t>
             </a:r>
-            <a:endParaRPr lang="en-US"/>
+            <a:endParaRPr lang="de-DE"/>
           </a:p>
         </p:txBody>
       </p:sp>
@@ -261,10 +261,10 @@
           </a:lstStyle>
           <a:p>
             <a:r>
-              <a:rPr lang="en-US" smtClean="0"/>
+              <a:rPr lang="de-DE" smtClean="0"/>
               <a:t>Click to edit Master subtitle style</a:t>
             </a:r>
-            <a:endParaRPr lang="en-US"/>
+            <a:endParaRPr lang="de-DE"/>
           </a:p>
         </p:txBody>
       </p:sp>
@@ -284,10 +284,10 @@
           <a:lstStyle/>
           <a:p>
             <a:fld id="{5BCAD085-E8A6-8845-BD4E-CB4CCA059FC4}" type="datetimeFigureOut">
-              <a:rPr lang="en-US" smtClean="0"/>
+              <a:rPr lang="de-DE" smtClean="0"/>
               <a:t>1/27/13</a:t>
             </a:fld>
-            <a:endParaRPr lang="en-US"/>
+            <a:endParaRPr lang="de-DE"/>
           </a:p>
         </p:txBody>
       </p:sp>
@@ -306,7 +306,7 @@
           <a:bodyPr/>
           <a:lstStyle/>
           <a:p>
-            <a:endParaRPr lang="en-US"/>
+            <a:endParaRPr lang="de-DE"/>
           </a:p>
         </p:txBody>
       </p:sp>
@@ -326,10 +326,10 @@
           <a:lstStyle/>
           <a:p>
             <a:fld id="{C1FF6DA9-008F-8B48-92A6-B652298478BF}" type="slidenum">
-              <a:rPr lang="en-US" smtClean="0"/>
+              <a:rPr lang="de-DE" smtClean="0"/>
               <a:t>‹#›</a:t>
             </a:fld>
-            <a:endParaRPr lang="en-US"/>
+            <a:endParaRPr lang="de-DE"/>
           </a:p>
         </p:txBody>
       </p:sp>
@@ -379,10 +379,10 @@
           <a:lstStyle/>
           <a:p>
             <a:r>
-              <a:rPr lang="en-US" smtClean="0"/>
+              <a:rPr lang="de-DE" smtClean="0"/>
               <a:t>Click to edit Master title style</a:t>
             </a:r>
-            <a:endParaRPr lang="en-US"/>
+            <a:endParaRPr lang="de-DE"/>
           </a:p>
         </p:txBody>
       </p:sp>
@@ -403,38 +403,38 @@
           <a:p>
             <a:pPr lvl="0"/>
             <a:r>
-              <a:rPr lang="en-US" smtClean="0"/>
+              <a:rPr lang="de-DE" smtClean="0"/>
               <a:t>Click to edit Master text styles</a:t>
             </a:r>
           </a:p>
           <a:p>
             <a:pPr lvl="1"/>
             <a:r>
-              <a:rPr lang="en-US" smtClean="0"/>
+              <a:rPr lang="de-DE" smtClean="0"/>
               <a:t>Second level</a:t>
             </a:r>
           </a:p>
           <a:p>
             <a:pPr lvl="2"/>
             <a:r>
-              <a:rPr lang="en-US" smtClean="0"/>
+              <a:rPr lang="de-DE" smtClean="0"/>
               <a:t>Third level</a:t>
             </a:r>
           </a:p>
           <a:p>
             <a:pPr lvl="3"/>
             <a:r>
-              <a:rPr lang="en-US" smtClean="0"/>
+              <a:rPr lang="de-DE" smtClean="0"/>
               <a:t>Fourth level</a:t>
             </a:r>
           </a:p>
           <a:p>
             <a:pPr lvl="4"/>
             <a:r>
-              <a:rPr lang="en-US" smtClean="0"/>
+              <a:rPr lang="de-DE" smtClean="0"/>
               <a:t>Fifth level</a:t>
             </a:r>
-            <a:endParaRPr lang="en-US"/>
+            <a:endParaRPr lang="de-DE"/>
           </a:p>
         </p:txBody>
       </p:sp>
@@ -454,10 +454,10 @@
           <a:lstStyle/>
           <a:p>
             <a:fld id="{5BCAD085-E8A6-8845-BD4E-CB4CCA059FC4}" type="datetimeFigureOut">
-              <a:rPr lang="en-US" smtClean="0"/>
+              <a:rPr lang="de-DE" smtClean="0"/>
               <a:t>1/27/13</a:t>
             </a:fld>
-            <a:endParaRPr lang="en-US"/>
+            <a:endParaRPr lang="de-DE"/>
           </a:p>
         </p:txBody>
       </p:sp>
@@ -476,7 +476,7 @@
           <a:bodyPr/>
           <a:lstStyle/>
           <a:p>
-            <a:endParaRPr lang="en-US"/>
+            <a:endParaRPr lang="de-DE"/>
           </a:p>
         </p:txBody>
       </p:sp>
@@ -496,10 +496,10 @@
           <a:lstStyle/>
           <a:p>
             <a:fld id="{C1FF6DA9-008F-8B48-92A6-B652298478BF}" type="slidenum">
-              <a:rPr lang="en-US" smtClean="0"/>
+              <a:rPr lang="de-DE" smtClean="0"/>
               <a:t>‹#›</a:t>
             </a:fld>
-            <a:endParaRPr lang="en-US"/>
+            <a:endParaRPr lang="de-DE"/>
           </a:p>
         </p:txBody>
       </p:sp>
@@ -554,10 +554,10 @@
           <a:lstStyle/>
           <a:p>
             <a:r>
-              <a:rPr lang="en-US" smtClean="0"/>
+              <a:rPr lang="de-DE" smtClean="0"/>
               <a:t>Click to edit Master title style</a:t>
             </a:r>
-            <a:endParaRPr lang="en-US"/>
+            <a:endParaRPr lang="de-DE"/>
           </a:p>
         </p:txBody>
       </p:sp>
@@ -583,38 +583,38 @@
           <a:p>
             <a:pPr lvl="0"/>
             <a:r>
-              <a:rPr lang="en-US" smtClean="0"/>
+              <a:rPr lang="de-DE" smtClean="0"/>
               <a:t>Click to edit Master text styles</a:t>
             </a:r>
           </a:p>
           <a:p>
             <a:pPr lvl="1"/>
             <a:r>
-              <a:rPr lang="en-US" smtClean="0"/>
+              <a:rPr lang="de-DE" smtClean="0"/>
               <a:t>Second level</a:t>
             </a:r>
           </a:p>
           <a:p>
             <a:pPr lvl="2"/>
             <a:r>
-              <a:rPr lang="en-US" smtClean="0"/>
+              <a:rPr lang="de-DE" smtClean="0"/>
               <a:t>Third level</a:t>
             </a:r>
           </a:p>
           <a:p>
             <a:pPr lvl="3"/>
             <a:r>
-              <a:rPr lang="en-US" smtClean="0"/>
+              <a:rPr lang="de-DE" smtClean="0"/>
               <a:t>Fourth level</a:t>
             </a:r>
           </a:p>
           <a:p>
             <a:pPr lvl="4"/>
             <a:r>
-              <a:rPr lang="en-US" smtClean="0"/>
+              <a:rPr lang="de-DE" smtClean="0"/>
               <a:t>Fifth level</a:t>
             </a:r>
-            <a:endParaRPr lang="en-US"/>
+            <a:endParaRPr lang="de-DE"/>
           </a:p>
         </p:txBody>
       </p:sp>
@@ -634,10 +634,10 @@
           <a:lstStyle/>
           <a:p>
             <a:fld id="{5BCAD085-E8A6-8845-BD4E-CB4CCA059FC4}" type="datetimeFigureOut">
-              <a:rPr lang="en-US" smtClean="0"/>
+              <a:rPr lang="de-DE" smtClean="0"/>
               <a:t>1/27/13</a:t>
             </a:fld>
-            <a:endParaRPr lang="en-US"/>
+            <a:endParaRPr lang="de-DE"/>
           </a:p>
         </p:txBody>
       </p:sp>
@@ -656,7 +656,7 @@
           <a:bodyPr/>
           <a:lstStyle/>
           <a:p>
-            <a:endParaRPr lang="en-US"/>
+            <a:endParaRPr lang="de-DE"/>
           </a:p>
         </p:txBody>
       </p:sp>
@@ -676,10 +676,10 @@
           <a:lstStyle/>
           <a:p>
             <a:fld id="{C1FF6DA9-008F-8B48-92A6-B652298478BF}" type="slidenum">
-              <a:rPr lang="en-US" smtClean="0"/>
+              <a:rPr lang="de-DE" smtClean="0"/>
               <a:t>‹#›</a:t>
             </a:fld>
-            <a:endParaRPr lang="en-US"/>
+            <a:endParaRPr lang="de-DE"/>
           </a:p>
         </p:txBody>
       </p:sp>
@@ -729,10 +729,10 @@
           <a:lstStyle/>
           <a:p>
             <a:r>
-              <a:rPr lang="en-US" smtClean="0"/>
+              <a:rPr lang="de-DE" smtClean="0"/>
               <a:t>Click to edit Master title style</a:t>
             </a:r>
-            <a:endParaRPr lang="en-US"/>
+            <a:endParaRPr lang="de-DE"/>
           </a:p>
         </p:txBody>
       </p:sp>
@@ -753,38 +753,38 @@
           <a:p>
             <a:pPr lvl="0"/>
             <a:r>
-              <a:rPr lang="en-US" smtClean="0"/>
+              <a:rPr lang="de-DE" smtClean="0"/>
               <a:t>Click to edit Master text styles</a:t>
             </a:r>
           </a:p>
           <a:p>
             <a:pPr lvl="1"/>
             <a:r>
-              <a:rPr lang="en-US" smtClean="0"/>
+              <a:rPr lang="de-DE" smtClean="0"/>
               <a:t>Second level</a:t>
             </a:r>
           </a:p>
           <a:p>
             <a:pPr lvl="2"/>
             <a:r>
-              <a:rPr lang="en-US" smtClean="0"/>
+              <a:rPr lang="de-DE" smtClean="0"/>
               <a:t>Third level</a:t>
             </a:r>
           </a:p>
           <a:p>
             <a:pPr lvl="3"/>
             <a:r>
-              <a:rPr lang="en-US" smtClean="0"/>
+              <a:rPr lang="de-DE" smtClean="0"/>
               <a:t>Fourth level</a:t>
             </a:r>
           </a:p>
           <a:p>
             <a:pPr lvl="4"/>
             <a:r>
-              <a:rPr lang="en-US" smtClean="0"/>
+              <a:rPr lang="de-DE" smtClean="0"/>
               <a:t>Fifth level</a:t>
             </a:r>
-            <a:endParaRPr lang="en-US"/>
+            <a:endParaRPr lang="de-DE"/>
           </a:p>
         </p:txBody>
       </p:sp>
@@ -804,10 +804,10 @@
           <a:lstStyle/>
           <a:p>
             <a:fld id="{5BCAD085-E8A6-8845-BD4E-CB4CCA059FC4}" type="datetimeFigureOut">
-              <a:rPr lang="en-US" smtClean="0"/>
+              <a:rPr lang="de-DE" smtClean="0"/>
               <a:t>1/27/13</a:t>
             </a:fld>
-            <a:endParaRPr lang="en-US"/>
+            <a:endParaRPr lang="de-DE"/>
           </a:p>
         </p:txBody>
       </p:sp>
@@ -826,7 +826,7 @@
           <a:bodyPr/>
           <a:lstStyle/>
           <a:p>
-            <a:endParaRPr lang="en-US"/>
+            <a:endParaRPr lang="de-DE"/>
           </a:p>
         </p:txBody>
       </p:sp>
@@ -846,10 +846,10 @@
           <a:lstStyle/>
           <a:p>
             <a:fld id="{C1FF6DA9-008F-8B48-92A6-B652298478BF}" type="slidenum">
-              <a:rPr lang="en-US" smtClean="0"/>
+              <a:rPr lang="de-DE" smtClean="0"/>
               <a:t>‹#›</a:t>
             </a:fld>
-            <a:endParaRPr lang="en-US"/>
+            <a:endParaRPr lang="de-DE"/>
           </a:p>
         </p:txBody>
       </p:sp>
@@ -908,10 +908,10 @@
           </a:lstStyle>
           <a:p>
             <a:r>
-              <a:rPr lang="en-US" smtClean="0"/>
+              <a:rPr lang="de-DE" smtClean="0"/>
               <a:t>Click to edit Master title style</a:t>
             </a:r>
-            <a:endParaRPr lang="en-US"/>
+            <a:endParaRPr lang="de-DE"/>
           </a:p>
         </p:txBody>
       </p:sp>
@@ -1028,7 +1028,7 @@
           <a:p>
             <a:pPr lvl="0"/>
             <a:r>
-              <a:rPr lang="en-US" smtClean="0"/>
+              <a:rPr lang="de-DE" smtClean="0"/>
               <a:t>Click to edit Master text styles</a:t>
             </a:r>
           </a:p>
@@ -1050,10 +1050,10 @@
           <a:lstStyle/>
           <a:p>
             <a:fld id="{5BCAD085-E8A6-8845-BD4E-CB4CCA059FC4}" type="datetimeFigureOut">
-              <a:rPr lang="en-US" smtClean="0"/>
+              <a:rPr lang="de-DE" smtClean="0"/>
               <a:t>1/27/13</a:t>
             </a:fld>
-            <a:endParaRPr lang="en-US"/>
+            <a:endParaRPr lang="de-DE"/>
           </a:p>
         </p:txBody>
       </p:sp>
@@ -1072,7 +1072,7 @@
           <a:bodyPr/>
           <a:lstStyle/>
           <a:p>
-            <a:endParaRPr lang="en-US"/>
+            <a:endParaRPr lang="de-DE"/>
           </a:p>
         </p:txBody>
       </p:sp>
@@ -1092,10 +1092,10 @@
           <a:lstStyle/>
           <a:p>
             <a:fld id="{C1FF6DA9-008F-8B48-92A6-B652298478BF}" type="slidenum">
-              <a:rPr lang="en-US" smtClean="0"/>
+              <a:rPr lang="de-DE" smtClean="0"/>
               <a:t>‹#›</a:t>
             </a:fld>
-            <a:endParaRPr lang="en-US"/>
+            <a:endParaRPr lang="de-DE"/>
           </a:p>
         </p:txBody>
       </p:sp>
@@ -1145,10 +1145,10 @@
           <a:lstStyle/>
           <a:p>
             <a:r>
-              <a:rPr lang="en-US" smtClean="0"/>
+              <a:rPr lang="de-DE" smtClean="0"/>
               <a:t>Click to edit Master title style</a:t>
             </a:r>
-            <a:endParaRPr lang="en-US"/>
+            <a:endParaRPr lang="de-DE"/>
           </a:p>
         </p:txBody>
       </p:sp>
@@ -1202,38 +1202,38 @@
           <a:p>
             <a:pPr lvl="0"/>
             <a:r>
-              <a:rPr lang="en-US" smtClean="0"/>
+              <a:rPr lang="de-DE" smtClean="0"/>
               <a:t>Click to edit Master text styles</a:t>
             </a:r>
           </a:p>
           <a:p>
             <a:pPr lvl="1"/>
             <a:r>
-              <a:rPr lang="en-US" smtClean="0"/>
+              <a:rPr lang="de-DE" smtClean="0"/>
               <a:t>Second level</a:t>
             </a:r>
           </a:p>
           <a:p>
             <a:pPr lvl="2"/>
             <a:r>
-              <a:rPr lang="en-US" smtClean="0"/>
+              <a:rPr lang="de-DE" smtClean="0"/>
               <a:t>Third level</a:t>
             </a:r>
           </a:p>
           <a:p>
             <a:pPr lvl="3"/>
             <a:r>
-              <a:rPr lang="en-US" smtClean="0"/>
+              <a:rPr lang="de-DE" smtClean="0"/>
               <a:t>Fourth level</a:t>
             </a:r>
           </a:p>
           <a:p>
             <a:pPr lvl="4"/>
             <a:r>
-              <a:rPr lang="en-US" smtClean="0"/>
+              <a:rPr lang="de-DE" smtClean="0"/>
               <a:t>Fifth level</a:t>
             </a:r>
-            <a:endParaRPr lang="en-US"/>
+            <a:endParaRPr lang="de-DE"/>
           </a:p>
         </p:txBody>
       </p:sp>
@@ -1287,38 +1287,38 @@
           <a:p>
             <a:pPr lvl="0"/>
             <a:r>
-              <a:rPr lang="en-US" smtClean="0"/>
+              <a:rPr lang="de-DE" smtClean="0"/>
               <a:t>Click to edit Master text styles</a:t>
             </a:r>
           </a:p>
           <a:p>
             <a:pPr lvl="1"/>
             <a:r>
-              <a:rPr lang="en-US" smtClean="0"/>
+              <a:rPr lang="de-DE" smtClean="0"/>
               <a:t>Second level</a:t>
             </a:r>
           </a:p>
           <a:p>
             <a:pPr lvl="2"/>
             <a:r>
-              <a:rPr lang="en-US" smtClean="0"/>
+              <a:rPr lang="de-DE" smtClean="0"/>
               <a:t>Third level</a:t>
             </a:r>
           </a:p>
           <a:p>
             <a:pPr lvl="3"/>
             <a:r>
-              <a:rPr lang="en-US" smtClean="0"/>
+              <a:rPr lang="de-DE" smtClean="0"/>
               <a:t>Fourth level</a:t>
             </a:r>
           </a:p>
           <a:p>
             <a:pPr lvl="4"/>
             <a:r>
-              <a:rPr lang="en-US" smtClean="0"/>
+              <a:rPr lang="de-DE" smtClean="0"/>
               <a:t>Fifth level</a:t>
             </a:r>
-            <a:endParaRPr lang="en-US"/>
+            <a:endParaRPr lang="de-DE"/>
           </a:p>
         </p:txBody>
       </p:sp>
@@ -1338,10 +1338,10 @@
           <a:lstStyle/>
           <a:p>
             <a:fld id="{5BCAD085-E8A6-8845-BD4E-CB4CCA059FC4}" type="datetimeFigureOut">
-              <a:rPr lang="en-US" smtClean="0"/>
+              <a:rPr lang="de-DE" smtClean="0"/>
               <a:t>1/27/13</a:t>
             </a:fld>
-            <a:endParaRPr lang="en-US"/>
+            <a:endParaRPr lang="de-DE"/>
           </a:p>
         </p:txBody>
       </p:sp>
@@ -1360,7 +1360,7 @@
           <a:bodyPr/>
           <a:lstStyle/>
           <a:p>
-            <a:endParaRPr lang="en-US"/>
+            <a:endParaRPr lang="de-DE"/>
           </a:p>
         </p:txBody>
       </p:sp>
@@ -1380,10 +1380,10 @@
           <a:lstStyle/>
           <a:p>
             <a:fld id="{C1FF6DA9-008F-8B48-92A6-B652298478BF}" type="slidenum">
-              <a:rPr lang="en-US" smtClean="0"/>
+              <a:rPr lang="de-DE" smtClean="0"/>
               <a:t>‹#›</a:t>
             </a:fld>
-            <a:endParaRPr lang="en-US"/>
+            <a:endParaRPr lang="de-DE"/>
           </a:p>
         </p:txBody>
       </p:sp>
@@ -1437,10 +1437,10 @@
           </a:lstStyle>
           <a:p>
             <a:r>
-              <a:rPr lang="en-US" smtClean="0"/>
+              <a:rPr lang="de-DE" smtClean="0"/>
               <a:t>Click to edit Master title style</a:t>
             </a:r>
-            <a:endParaRPr lang="en-US"/>
+            <a:endParaRPr lang="de-DE"/>
           </a:p>
         </p:txBody>
       </p:sp>
@@ -1503,7 +1503,7 @@
           <a:p>
             <a:pPr lvl="0"/>
             <a:r>
-              <a:rPr lang="en-US" smtClean="0"/>
+              <a:rPr lang="de-DE" smtClean="0"/>
               <a:t>Click to edit Master text styles</a:t>
             </a:r>
           </a:p>
@@ -1559,38 +1559,38 @@
           <a:p>
             <a:pPr lvl="0"/>
             <a:r>
-              <a:rPr lang="en-US" smtClean="0"/>
+              <a:rPr lang="de-DE" smtClean="0"/>
               <a:t>Click to edit Master text styles</a:t>
             </a:r>
           </a:p>
           <a:p>
             <a:pPr lvl="1"/>
             <a:r>
-              <a:rPr lang="en-US" smtClean="0"/>
+              <a:rPr lang="de-DE" smtClean="0"/>
               <a:t>Second level</a:t>
             </a:r>
           </a:p>
           <a:p>
             <a:pPr lvl="2"/>
             <a:r>
-              <a:rPr lang="en-US" smtClean="0"/>
+              <a:rPr lang="de-DE" smtClean="0"/>
               <a:t>Third level</a:t>
             </a:r>
           </a:p>
           <a:p>
             <a:pPr lvl="3"/>
             <a:r>
-              <a:rPr lang="en-US" smtClean="0"/>
+              <a:rPr lang="de-DE" smtClean="0"/>
               <a:t>Fourth level</a:t>
             </a:r>
           </a:p>
           <a:p>
             <a:pPr lvl="4"/>
             <a:r>
-              <a:rPr lang="en-US" smtClean="0"/>
+              <a:rPr lang="de-DE" smtClean="0"/>
               <a:t>Fifth level</a:t>
             </a:r>
-            <a:endParaRPr lang="en-US"/>
+            <a:endParaRPr lang="de-DE"/>
           </a:p>
         </p:txBody>
       </p:sp>
@@ -1653,7 +1653,7 @@
           <a:p>
             <a:pPr lvl="0"/>
             <a:r>
-              <a:rPr lang="en-US" smtClean="0"/>
+              <a:rPr lang="de-DE" smtClean="0"/>
               <a:t>Click to edit Master text styles</a:t>
             </a:r>
           </a:p>
@@ -1709,38 +1709,38 @@
           <a:p>
             <a:pPr lvl="0"/>
             <a:r>
-              <a:rPr lang="en-US" smtClean="0"/>
+              <a:rPr lang="de-DE" smtClean="0"/>
               <a:t>Click to edit Master text styles</a:t>
             </a:r>
           </a:p>
           <a:p>
             <a:pPr lvl="1"/>
             <a:r>
-              <a:rPr lang="en-US" smtClean="0"/>
+              <a:rPr lang="de-DE" smtClean="0"/>
               <a:t>Second level</a:t>
             </a:r>
           </a:p>
           <a:p>
             <a:pPr lvl="2"/>
             <a:r>
-              <a:rPr lang="en-US" smtClean="0"/>
+              <a:rPr lang="de-DE" smtClean="0"/>
               <a:t>Third level</a:t>
             </a:r>
           </a:p>
           <a:p>
             <a:pPr lvl="3"/>
             <a:r>
-              <a:rPr lang="en-US" smtClean="0"/>
+              <a:rPr lang="de-DE" smtClean="0"/>
               <a:t>Fourth level</a:t>
             </a:r>
           </a:p>
           <a:p>
             <a:pPr lvl="4"/>
             <a:r>
-              <a:rPr lang="en-US" smtClean="0"/>
+              <a:rPr lang="de-DE" smtClean="0"/>
               <a:t>Fifth level</a:t>
             </a:r>
-            <a:endParaRPr lang="en-US"/>
+            <a:endParaRPr lang="de-DE"/>
           </a:p>
         </p:txBody>
       </p:sp>
@@ -1760,10 +1760,10 @@
           <a:lstStyle/>
           <a:p>
             <a:fld id="{5BCAD085-E8A6-8845-BD4E-CB4CCA059FC4}" type="datetimeFigureOut">
-              <a:rPr lang="en-US" smtClean="0"/>
+              <a:rPr lang="de-DE" smtClean="0"/>
               <a:t>1/27/13</a:t>
             </a:fld>
-            <a:endParaRPr lang="en-US"/>
+            <a:endParaRPr lang="de-DE"/>
           </a:p>
         </p:txBody>
       </p:sp>
@@ -1782,7 +1782,7 @@
           <a:bodyPr/>
           <a:lstStyle/>
           <a:p>
-            <a:endParaRPr lang="en-US"/>
+            <a:endParaRPr lang="de-DE"/>
           </a:p>
         </p:txBody>
       </p:sp>
@@ -1802,10 +1802,10 @@
           <a:lstStyle/>
           <a:p>
             <a:fld id="{C1FF6DA9-008F-8B48-92A6-B652298478BF}" type="slidenum">
-              <a:rPr lang="en-US" smtClean="0"/>
+              <a:rPr lang="de-DE" smtClean="0"/>
               <a:t>‹#›</a:t>
             </a:fld>
-            <a:endParaRPr lang="en-US"/>
+            <a:endParaRPr lang="de-DE"/>
           </a:p>
         </p:txBody>
       </p:sp>
@@ -1855,10 +1855,10 @@
           <a:lstStyle/>
           <a:p>
             <a:r>
-              <a:rPr lang="en-US" smtClean="0"/>
+              <a:rPr lang="de-DE" smtClean="0"/>
               <a:t>Click to edit Master title style</a:t>
             </a:r>
-            <a:endParaRPr lang="en-US"/>
+            <a:endParaRPr lang="de-DE"/>
           </a:p>
         </p:txBody>
       </p:sp>
@@ -1878,10 +1878,10 @@
           <a:lstStyle/>
           <a:p>
             <a:fld id="{5BCAD085-E8A6-8845-BD4E-CB4CCA059FC4}" type="datetimeFigureOut">
-              <a:rPr lang="en-US" smtClean="0"/>
+              <a:rPr lang="de-DE" smtClean="0"/>
               <a:t>1/27/13</a:t>
             </a:fld>
-            <a:endParaRPr lang="en-US"/>
+            <a:endParaRPr lang="de-DE"/>
           </a:p>
         </p:txBody>
       </p:sp>
@@ -1900,7 +1900,7 @@
           <a:bodyPr/>
           <a:lstStyle/>
           <a:p>
-            <a:endParaRPr lang="en-US"/>
+            <a:endParaRPr lang="de-DE"/>
           </a:p>
         </p:txBody>
       </p:sp>
@@ -1920,10 +1920,10 @@
           <a:lstStyle/>
           <a:p>
             <a:fld id="{C1FF6DA9-008F-8B48-92A6-B652298478BF}" type="slidenum">
-              <a:rPr lang="en-US" smtClean="0"/>
+              <a:rPr lang="de-DE" smtClean="0"/>
               <a:t>‹#›</a:t>
             </a:fld>
-            <a:endParaRPr lang="en-US"/>
+            <a:endParaRPr lang="de-DE"/>
           </a:p>
         </p:txBody>
       </p:sp>
@@ -1973,10 +1973,10 @@
           <a:lstStyle/>
           <a:p>
             <a:fld id="{5BCAD085-E8A6-8845-BD4E-CB4CCA059FC4}" type="datetimeFigureOut">
-              <a:rPr lang="en-US" smtClean="0"/>
+              <a:rPr lang="de-DE" smtClean="0"/>
               <a:t>1/27/13</a:t>
             </a:fld>
-            <a:endParaRPr lang="en-US"/>
+            <a:endParaRPr lang="de-DE"/>
           </a:p>
         </p:txBody>
       </p:sp>
@@ -1995,7 +1995,7 @@
           <a:bodyPr/>
           <a:lstStyle/>
           <a:p>
-            <a:endParaRPr lang="en-US"/>
+            <a:endParaRPr lang="de-DE"/>
           </a:p>
         </p:txBody>
       </p:sp>
@@ -2015,10 +2015,10 @@
           <a:lstStyle/>
           <a:p>
             <a:fld id="{C1FF6DA9-008F-8B48-92A6-B652298478BF}" type="slidenum">
-              <a:rPr lang="en-US" smtClean="0"/>
+              <a:rPr lang="de-DE" smtClean="0"/>
               <a:t>‹#›</a:t>
             </a:fld>
-            <a:endParaRPr lang="en-US"/>
+            <a:endParaRPr lang="de-DE"/>
           </a:p>
         </p:txBody>
       </p:sp>
@@ -2077,10 +2077,10 @@
           </a:lstStyle>
           <a:p>
             <a:r>
-              <a:rPr lang="en-US" smtClean="0"/>
+              <a:rPr lang="de-DE" smtClean="0"/>
               <a:t>Click to edit Master title style</a:t>
             </a:r>
-            <a:endParaRPr lang="en-US"/>
+            <a:endParaRPr lang="de-DE"/>
           </a:p>
         </p:txBody>
       </p:sp>
@@ -2134,38 +2134,38 @@
           <a:p>
             <a:pPr lvl="0"/>
             <a:r>
-              <a:rPr lang="en-US" smtClean="0"/>
+              <a:rPr lang="de-DE" smtClean="0"/>
               <a:t>Click to edit Master text styles</a:t>
             </a:r>
           </a:p>
           <a:p>
             <a:pPr lvl="1"/>
             <a:r>
-              <a:rPr lang="en-US" smtClean="0"/>
+              <a:rPr lang="de-DE" smtClean="0"/>
               <a:t>Second level</a:t>
             </a:r>
           </a:p>
           <a:p>
             <a:pPr lvl="2"/>
             <a:r>
-              <a:rPr lang="en-US" smtClean="0"/>
+              <a:rPr lang="de-DE" smtClean="0"/>
               <a:t>Third level</a:t>
             </a:r>
           </a:p>
           <a:p>
             <a:pPr lvl="3"/>
             <a:r>
-              <a:rPr lang="en-US" smtClean="0"/>
+              <a:rPr lang="de-DE" smtClean="0"/>
               <a:t>Fourth level</a:t>
             </a:r>
           </a:p>
           <a:p>
             <a:pPr lvl="4"/>
             <a:r>
-              <a:rPr lang="en-US" smtClean="0"/>
+              <a:rPr lang="de-DE" smtClean="0"/>
               <a:t>Fifth level</a:t>
             </a:r>
-            <a:endParaRPr lang="en-US"/>
+            <a:endParaRPr lang="de-DE"/>
           </a:p>
         </p:txBody>
       </p:sp>
@@ -2228,7 +2228,7 @@
           <a:p>
             <a:pPr lvl="0"/>
             <a:r>
-              <a:rPr lang="en-US" smtClean="0"/>
+              <a:rPr lang="de-DE" smtClean="0"/>
               <a:t>Click to edit Master text styles</a:t>
             </a:r>
           </a:p>
@@ -2250,10 +2250,10 @@
           <a:lstStyle/>
           <a:p>
             <a:fld id="{5BCAD085-E8A6-8845-BD4E-CB4CCA059FC4}" type="datetimeFigureOut">
-              <a:rPr lang="en-US" smtClean="0"/>
+              <a:rPr lang="de-DE" smtClean="0"/>
               <a:t>1/27/13</a:t>
             </a:fld>
-            <a:endParaRPr lang="en-US"/>
+            <a:endParaRPr lang="de-DE"/>
           </a:p>
         </p:txBody>
       </p:sp>
@@ -2272,7 +2272,7 @@
           <a:bodyPr/>
           <a:lstStyle/>
           <a:p>
-            <a:endParaRPr lang="en-US"/>
+            <a:endParaRPr lang="de-DE"/>
           </a:p>
         </p:txBody>
       </p:sp>
@@ -2292,10 +2292,10 @@
           <a:lstStyle/>
           <a:p>
             <a:fld id="{C1FF6DA9-008F-8B48-92A6-B652298478BF}" type="slidenum">
-              <a:rPr lang="en-US" smtClean="0"/>
+              <a:rPr lang="de-DE" smtClean="0"/>
               <a:t>‹#›</a:t>
             </a:fld>
-            <a:endParaRPr lang="en-US"/>
+            <a:endParaRPr lang="de-DE"/>
           </a:p>
         </p:txBody>
       </p:sp>
@@ -2354,10 +2354,10 @@
           </a:lstStyle>
           <a:p>
             <a:r>
-              <a:rPr lang="en-US" smtClean="0"/>
+              <a:rPr lang="de-DE" smtClean="0"/>
               <a:t>Click to edit Master title style</a:t>
             </a:r>
-            <a:endParaRPr lang="en-US"/>
+            <a:endParaRPr lang="de-DE"/>
           </a:p>
         </p:txBody>
       </p:sp>
@@ -2418,7 +2418,7 @@
             </a:lvl9pPr>
           </a:lstStyle>
           <a:p>
-            <a:endParaRPr lang="en-US"/>
+            <a:endParaRPr lang="de-DE"/>
           </a:p>
         </p:txBody>
       </p:sp>
@@ -2481,7 +2481,7 @@
           <a:p>
             <a:pPr lvl="0"/>
             <a:r>
-              <a:rPr lang="en-US" smtClean="0"/>
+              <a:rPr lang="de-DE" smtClean="0"/>
               <a:t>Click to edit Master text styles</a:t>
             </a:r>
           </a:p>
@@ -2503,10 +2503,10 @@
           <a:lstStyle/>
           <a:p>
             <a:fld id="{5BCAD085-E8A6-8845-BD4E-CB4CCA059FC4}" type="datetimeFigureOut">
-              <a:rPr lang="en-US" smtClean="0"/>
+              <a:rPr lang="de-DE" smtClean="0"/>
               <a:t>1/27/13</a:t>
             </a:fld>
-            <a:endParaRPr lang="en-US"/>
+            <a:endParaRPr lang="de-DE"/>
           </a:p>
         </p:txBody>
       </p:sp>
@@ -2525,7 +2525,7 @@
           <a:bodyPr/>
           <a:lstStyle/>
           <a:p>
-            <a:endParaRPr lang="en-US"/>
+            <a:endParaRPr lang="de-DE"/>
           </a:p>
         </p:txBody>
       </p:sp>
@@ -2545,10 +2545,10 @@
           <a:lstStyle/>
           <a:p>
             <a:fld id="{C1FF6DA9-008F-8B48-92A6-B652298478BF}" type="slidenum">
-              <a:rPr lang="en-US" smtClean="0"/>
+              <a:rPr lang="de-DE" smtClean="0"/>
               <a:t>‹#›</a:t>
             </a:fld>
-            <a:endParaRPr lang="en-US"/>
+            <a:endParaRPr lang="de-DE"/>
           </a:p>
         </p:txBody>
       </p:sp>
@@ -2613,10 +2613,10 @@
           <a:lstStyle/>
           <a:p>
             <a:r>
-              <a:rPr lang="en-US" smtClean="0"/>
+              <a:rPr lang="de-DE" smtClean="0"/>
               <a:t>Click to edit Master title style</a:t>
             </a:r>
-            <a:endParaRPr lang="en-US"/>
+            <a:endParaRPr lang="de-DE"/>
           </a:p>
         </p:txBody>
       </p:sp>
@@ -2647,38 +2647,38 @@
           <a:p>
             <a:pPr lvl="0"/>
             <a:r>
-              <a:rPr lang="en-US" smtClean="0"/>
+              <a:rPr lang="de-DE" smtClean="0"/>
               <a:t>Click to edit Master text styles</a:t>
             </a:r>
           </a:p>
           <a:p>
             <a:pPr lvl="1"/>
             <a:r>
-              <a:rPr lang="en-US" smtClean="0"/>
+              <a:rPr lang="de-DE" smtClean="0"/>
               <a:t>Second level</a:t>
             </a:r>
           </a:p>
           <a:p>
             <a:pPr lvl="2"/>
             <a:r>
-              <a:rPr lang="en-US" smtClean="0"/>
+              <a:rPr lang="de-DE" smtClean="0"/>
               <a:t>Third level</a:t>
             </a:r>
           </a:p>
           <a:p>
             <a:pPr lvl="3"/>
             <a:r>
-              <a:rPr lang="en-US" smtClean="0"/>
+              <a:rPr lang="de-DE" smtClean="0"/>
               <a:t>Fourth level</a:t>
             </a:r>
           </a:p>
           <a:p>
             <a:pPr lvl="4"/>
             <a:r>
-              <a:rPr lang="en-US" smtClean="0"/>
+              <a:rPr lang="de-DE" smtClean="0"/>
               <a:t>Fifth level</a:t>
             </a:r>
-            <a:endParaRPr lang="en-US"/>
+            <a:endParaRPr lang="de-DE"/>
           </a:p>
         </p:txBody>
       </p:sp>
@@ -2716,10 +2716,10 @@
           </a:lstStyle>
           <a:p>
             <a:fld id="{5BCAD085-E8A6-8845-BD4E-CB4CCA059FC4}" type="datetimeFigureOut">
-              <a:rPr lang="en-US" smtClean="0"/>
+              <a:rPr lang="de-DE" smtClean="0"/>
               <a:t>1/27/13</a:t>
             </a:fld>
-            <a:endParaRPr lang="en-US"/>
+            <a:endParaRPr lang="de-DE"/>
           </a:p>
         </p:txBody>
       </p:sp>
@@ -2756,7 +2756,7 @@
             </a:lvl1pPr>
           </a:lstStyle>
           <a:p>
-            <a:endParaRPr lang="en-US"/>
+            <a:endParaRPr lang="de-DE"/>
           </a:p>
         </p:txBody>
       </p:sp>
@@ -2794,10 +2794,10 @@
           </a:lstStyle>
           <a:p>
             <a:fld id="{C1FF6DA9-008F-8B48-92A6-B652298478BF}" type="slidenum">
-              <a:rPr lang="en-US" smtClean="0"/>
+              <a:rPr lang="de-DE" smtClean="0"/>
               <a:t>‹#›</a:t>
             </a:fld>
-            <a:endParaRPr lang="en-US"/>
+            <a:endParaRPr lang="de-DE"/>
           </a:p>
         </p:txBody>
       </p:sp>
@@ -2978,7 +2978,7 @@
     </p:bodyStyle>
     <p:otherStyle>
       <a:defPPr>
-        <a:defRPr lang="en-US"/>
+        <a:defRPr lang="de-DE"/>
       </a:defPPr>
       <a:lvl1pPr marL="0" algn="l" defTabSz="457200" rtl="0" eaLnBrk="1" latinLnBrk="0" hangingPunct="1">
         <a:defRPr sz="1800" kern="1200">

</xml_diff>